<commit_message>
Update temporary PPTX (Futura body)
Co-Authored-By: Claude Opus 5.5 <noreply@anthropic.com>
Claude-Session: https://claude.ai/code/session_01WGBATs33Zx7QxitHnMT3nv
</commit_message>
<xml_diff>
--- a/alx/The-Alexandre-Email-Header.pptx
+++ b/alx/The-Alexandre-Email-Header.pptx
@@ -3165,7 +3165,7 @@
         <p:spPr>
           <a:xfrm>
             <a:off x="609600" y="2206555"/>
-            <a:ext cx="3509956" cy="160972"/>
+            <a:ext cx="3964950" cy="160972"/>
           </a:xfrm>
           <a:prstGeom prst="rect">
             <a:avLst/>
@@ -3186,9 +3186,9 @@
                 <a:solidFill>
                   <a:srgbClr val="FFFFFF"/>
                 </a:solidFill>
-                <a:latin typeface="Jost"/>
-                <a:ea typeface="Jost"/>
-                <a:cs typeface="Jost"/>
+                <a:latin typeface="Futura"/>
+                <a:ea typeface="Futura"/>
+                <a:cs typeface="Futura"/>
               </a:rPr>
               <a:t>CONDO FINANCING AT THE ALEXANDRE</a:t>
             </a:r>
@@ -3204,7 +3204,7 @@
         <p:spPr>
           <a:xfrm>
             <a:off x="609600" y="2449874"/>
-            <a:ext cx="4076384" cy="544830"/>
+            <a:ext cx="4604804" cy="544830"/>
           </a:xfrm>
           <a:prstGeom prst="rect">
             <a:avLst/>
@@ -3243,7 +3243,7 @@
         <p:spPr>
           <a:xfrm>
             <a:off x="609600" y="3067050"/>
-            <a:ext cx="4268622" cy="552450"/>
+            <a:ext cx="4189574" cy="552450"/>
           </a:xfrm>
           <a:prstGeom prst="rect">
             <a:avLst/>
@@ -3264,9 +3264,9 @@
                 <a:solidFill>
                   <a:srgbClr val="FFFFFF"/>
                 </a:solidFill>
-                <a:latin typeface="Jost"/>
-                <a:ea typeface="Jost"/>
-                <a:cs typeface="Jost"/>
+                <a:latin typeface="Futura"/>
+                <a:ea typeface="Futura"/>
+                <a:cs typeface="Futura"/>
               </a:rPr>
               <a:t>Conventional condo financing for eligible primary-residence buyers.</a:t>
             </a:r>
@@ -3418,7 +3418,7 @@
         <p:spPr>
           <a:xfrm>
             <a:off x="1219200" y="3994487"/>
-            <a:ext cx="869007" cy="111442"/>
+            <a:ext cx="967225" cy="111442"/>
           </a:xfrm>
           <a:prstGeom prst="rect">
             <a:avLst/>
@@ -3439,9 +3439,9 @@
                 <a:solidFill>
                   <a:srgbClr val="FFFFFF"/>
                 </a:solidFill>
-                <a:latin typeface="Jost"/>
-                <a:ea typeface="Jost"/>
-                <a:cs typeface="Jost"/>
+                <a:latin typeface="Futura"/>
+                <a:ea typeface="Futura"/>
+                <a:cs typeface="Futura"/>
               </a:rPr>
               <a:t>YOUR LENDER</a:t>
             </a:r>
@@ -3457,7 +3457,7 @@
         <p:spPr>
           <a:xfrm>
             <a:off x="1219200" y="4122553"/>
-            <a:ext cx="1427481" cy="235267"/>
+            <a:ext cx="1612525" cy="235267"/>
           </a:xfrm>
           <a:prstGeom prst="rect">
             <a:avLst/>
@@ -3496,7 +3496,7 @@
         <p:spPr>
           <a:xfrm>
             <a:off x="1219200" y="4379684"/>
-            <a:ext cx="2553104" cy="148590"/>
+            <a:ext cx="2884062" cy="148590"/>
           </a:xfrm>
           <a:prstGeom prst="rect">
             <a:avLst/>
@@ -3517,9 +3517,9 @@
                 <a:solidFill>
                   <a:srgbClr val="FFFFFF"/>
                 </a:solidFill>
-                <a:latin typeface="Jost"/>
-                <a:ea typeface="Jost"/>
-                <a:cs typeface="Jost"/>
+                <a:latin typeface="Futura"/>
+                <a:ea typeface="Futura"/>
+                <a:cs typeface="Futura"/>
               </a:rPr>
               <a:t>Loan Officer | NMLS #1934694 | Eustis Mortgage</a:t>
             </a:r>
@@ -3535,7 +3535,7 @@
         <p:spPr>
           <a:xfrm>
             <a:off x="1219200" y="4579709"/>
-            <a:ext cx="2211705" cy="148590"/>
+            <a:ext cx="2498407" cy="148590"/>
           </a:xfrm>
           <a:prstGeom prst="rect">
             <a:avLst/>
@@ -3556,9 +3556,9 @@
                 <a:solidFill>
                   <a:srgbClr val="FFFFFF"/>
                 </a:solidFill>
-                <a:latin typeface="Jost"/>
-                <a:ea typeface="Jost"/>
-                <a:cs typeface="Jost"/>
+                <a:latin typeface="Futura"/>
+                <a:ea typeface="Futura"/>
+                <a:cs typeface="Futura"/>
               </a:rPr>
               <a:t>504.418.3416 | nate@eustismortgage.com</a:t>
             </a:r>
@@ -3642,7 +3642,7 @@
         <p:spPr>
           <a:xfrm>
             <a:off x="9784853" y="4584442"/>
-            <a:ext cx="1118389" cy="111442"/>
+            <a:ext cx="1263366" cy="111442"/>
           </a:xfrm>
           <a:prstGeom prst="rect">
             <a:avLst/>
@@ -3663,9 +3663,9 @@
                 <a:solidFill>
                   <a:srgbClr val="FFFFFF"/>
                 </a:solidFill>
-                <a:latin typeface="Jost"/>
-                <a:ea typeface="Jost"/>
-                <a:cs typeface="Jost"/>
+                <a:latin typeface="Futura"/>
+                <a:ea typeface="Futura"/>
+                <a:cs typeface="Futura"/>
               </a:rPr>
               <a:t>APPLY WITH NATE</a:t>
             </a:r>
@@ -3681,7 +3681,7 @@
         <p:spPr>
           <a:xfrm>
             <a:off x="609600" y="5036909"/>
-            <a:ext cx="1227689" cy="148590"/>
+            <a:ext cx="1386834" cy="148590"/>
           </a:xfrm>
           <a:prstGeom prst="rect">
             <a:avLst/>
@@ -3702,9 +3702,9 @@
                 <a:solidFill>
                   <a:srgbClr val="FFFFFF"/>
                 </a:solidFill>
-                <a:latin typeface="Jost"/>
-                <a:ea typeface="Jost"/>
-                <a:cs typeface="Jost"/>
+                <a:latin typeface="Futura"/>
+                <a:ea typeface="Futura"/>
+                <a:cs typeface="Futura"/>
               </a:rPr>
               <a:t>FINANCING BY</a:t>
             </a:r>
@@ -3768,7 +3768,7 @@
         <p:spPr>
           <a:xfrm>
             <a:off x="904875" y="5314503"/>
-            <a:ext cx="926752" cy="252412"/>
+            <a:ext cx="945802" cy="252412"/>
           </a:xfrm>
           <a:prstGeom prst="rect">
             <a:avLst/>
@@ -3789,9 +3789,9 @@
                 <a:solidFill>
                   <a:srgbClr val="FFFFFF"/>
                 </a:solidFill>
-                <a:latin typeface="Jost"/>
-                <a:ea typeface="Jost"/>
-                <a:cs typeface="Jost"/>
+                <a:latin typeface="Futura"/>
+                <a:ea typeface="Futura"/>
+                <a:cs typeface="Futura"/>
               </a:rPr>
               <a:t>EQUAL HOUSING</a:t>
             </a:r>
@@ -3807,9 +3807,9 @@
                 <a:solidFill>
                   <a:srgbClr val="FFFFFF"/>
                 </a:solidFill>
-                <a:latin typeface="Jost"/>
-                <a:ea typeface="Jost"/>
-                <a:cs typeface="Jost"/>
+                <a:latin typeface="Futura"/>
+                <a:ea typeface="Futura"/>
+                <a:cs typeface="Futura"/>
               </a:rPr>
               <a:t>OPPORTUNITY</a:t>
             </a:r>
@@ -3869,7 +3869,7 @@
         <p:spPr>
           <a:xfrm>
             <a:off x="1971972" y="5292179"/>
-            <a:ext cx="9352008" cy="293786"/>
+            <a:ext cx="9178822" cy="293786"/>
           </a:xfrm>
           <a:prstGeom prst="rect">
             <a:avLst/>
@@ -3890,9 +3890,9 @@
                 <a:solidFill>
                   <a:srgbClr val="FFFFFF"/>
                 </a:solidFill>
-                <a:latin typeface="Jost"/>
-                <a:ea typeface="Jost"/>
-                <a:cs typeface="Jost"/>
+                <a:latin typeface="Futura"/>
+                <a:ea typeface="Futura"/>
+                <a:cs typeface="Futura"/>
               </a:rPr>
               <a:t>CONVENTIONAL FINANCING OFFERED BY EUSTIS MORTGAGE CORPORATION. NOT A COMMITMENT TO LEND. ALL BORROWERS ARE SUBJECT TO CREDIT APPROVAL. RATES AND TERMS MAY CHANGE AT ANYTIME WITHOUT NOTICE. NMLS #70345</a:t>
             </a:r>

</xml_diff>

<commit_message>
Update temporary PPTX (approved EHO)
Co-Authored-By: Claude Opus 5.5 <noreply@anthropic.com>
Claude-Session: https://claude.ai/code/session_01WGBATs33Zx7QxitHnMT3nv
</commit_message>
<xml_diff>
--- a/alx/The-Alexandre-Email-Header.pptx
+++ b/alx/The-Alexandre-Email-Header.pptx
@@ -3349,7 +3349,7 @@
         </p:nvSpPr>
         <p:spPr>
           <a:xfrm>
-            <a:off x="609600" y="4834979"/>
+            <a:off x="609600" y="4727971"/>
             <a:ext cx="10210800" cy="9525"/>
           </a:xfrm>
           <a:prstGeom prst="rect">
@@ -3401,7 +3401,7 @@
         </p:blipFill>
         <p:spPr>
           <a:xfrm>
-            <a:off x="609600" y="4121050"/>
+            <a:off x="609600" y="4014043"/>
             <a:ext cx="485775" cy="485775"/>
           </a:xfrm>
           <a:prstGeom prst="rect">
@@ -3417,7 +3417,7 @@
         </p:nvSpPr>
         <p:spPr>
           <a:xfrm>
-            <a:off x="1219200" y="3994487"/>
+            <a:off x="1219200" y="3887479"/>
             <a:ext cx="967225" cy="111442"/>
           </a:xfrm>
           <a:prstGeom prst="rect">
@@ -3456,7 +3456,7 @@
         </p:nvSpPr>
         <p:spPr>
           <a:xfrm>
-            <a:off x="1219200" y="4122553"/>
+            <a:off x="1219200" y="4015546"/>
             <a:ext cx="1612525" cy="235267"/>
           </a:xfrm>
           <a:prstGeom prst="rect">
@@ -3495,7 +3495,7 @@
         </p:nvSpPr>
         <p:spPr>
           <a:xfrm>
-            <a:off x="1219200" y="4379684"/>
+            <a:off x="1219200" y="4272676"/>
             <a:ext cx="2884062" cy="148590"/>
           </a:xfrm>
           <a:prstGeom prst="rect">
@@ -3534,7 +3534,7 @@
         </p:nvSpPr>
         <p:spPr>
           <a:xfrm>
-            <a:off x="1219200" y="4579709"/>
+            <a:off x="1219200" y="4472701"/>
             <a:ext cx="2498407" cy="148590"/>
           </a:xfrm>
           <a:prstGeom prst="rect">
@@ -3573,7 +3573,7 @@
         </p:nvSpPr>
         <p:spPr>
           <a:xfrm>
-            <a:off x="10045451" y="4025800"/>
+            <a:off x="10045451" y="3918793"/>
             <a:ext cx="514350" cy="514350"/>
           </a:xfrm>
           <a:prstGeom prst="rect">
@@ -3625,7 +3625,7 @@
         </p:blipFill>
         <p:spPr>
           <a:xfrm>
-            <a:off x="10074026" y="4054375"/>
+            <a:off x="10074026" y="3947368"/>
             <a:ext cx="457200" cy="457200"/>
           </a:xfrm>
           <a:prstGeom prst="rect">
@@ -3641,7 +3641,7 @@
         </p:nvSpPr>
         <p:spPr>
           <a:xfrm>
-            <a:off x="9784853" y="4584442"/>
+            <a:off x="9784853" y="4477434"/>
             <a:ext cx="1263366" cy="111442"/>
           </a:xfrm>
           <a:prstGeom prst="rect">
@@ -3680,7 +3680,7 @@
         </p:nvSpPr>
         <p:spPr>
           <a:xfrm>
-            <a:off x="609600" y="5036909"/>
+            <a:off x="609600" y="4929901"/>
             <a:ext cx="1386834" cy="148590"/>
           </a:xfrm>
           <a:prstGeom prst="rect">
@@ -3727,7 +3727,7 @@
         </p:blipFill>
         <p:spPr>
           <a:xfrm>
-            <a:off x="1870174" y="4987379"/>
+            <a:off x="1870174" y="4880371"/>
             <a:ext cx="649039" cy="247650"/>
           </a:xfrm>
           <a:prstGeom prst="rect">
@@ -3735,9 +3735,48 @@
           </a:prstGeom>
         </p:spPr>
       </p:pic>
+      <p:sp>
+        <p:nvSpPr>
+          <p:cNvPr id="20" name="TextBox 19"/>
+          <p:cNvSpPr txBox="1"/>
+          <p:nvPr/>
+        </p:nvSpPr>
+        <p:spPr>
+          <a:xfrm>
+            <a:off x="609600" y="5197286"/>
+            <a:ext cx="3462909" cy="136207"/>
+          </a:xfrm>
+          <a:prstGeom prst="rect">
+            <a:avLst/>
+          </a:prstGeom>
+          <a:noFill/>
+        </p:spPr>
+        <p:txBody>
+          <a:bodyPr wrap="none" lIns="0" rIns="0" tIns="0" bIns="0" anchor="ctr"/>
+          <a:lstStyle/>
+          <a:p>
+            <a:pPr algn="l">
+              <a:lnSpc>
+                <a:spcPct val="100000"/>
+              </a:lnSpc>
+            </a:pPr>
+            <a:r>
+              <a:rPr sz="825" b="0" i="0">
+                <a:solidFill>
+                  <a:srgbClr val="FFFFFF"/>
+                </a:solidFill>
+                <a:latin typeface="Futura"/>
+                <a:ea typeface="Futura"/>
+                <a:cs typeface="Futura"/>
+              </a:rPr>
+              <a:t>Conventional financing offered by Eustis Mortgage Corporation.</a:t>
+            </a:r>
+          </a:p>
+        </p:txBody>
+      </p:sp>
       <p:pic>
         <p:nvPicPr>
-          <p:cNvPr id="20" name="Picture 19" descr="snap19.png"/>
+          <p:cNvPr id="21" name="Picture 20" descr="img20.png"/>
           <p:cNvPicPr>
             <a:picLocks noChangeAspect="1"/>
           </p:cNvPicPr>
@@ -3751,154 +3790,14 @@
         </p:blipFill>
         <p:spPr>
           <a:xfrm>
-            <a:off x="609600" y="5333553"/>
-            <a:ext cx="238125" cy="219075"/>
+            <a:off x="609600" y="5393233"/>
+            <a:ext cx="5181600" cy="298251"/>
           </a:xfrm>
           <a:prstGeom prst="rect">
             <a:avLst/>
           </a:prstGeom>
         </p:spPr>
       </p:pic>
-      <p:sp>
-        <p:nvSpPr>
-          <p:cNvPr id="21" name="TextBox 20"/>
-          <p:cNvSpPr txBox="1"/>
-          <p:nvPr/>
-        </p:nvSpPr>
-        <p:spPr>
-          <a:xfrm>
-            <a:off x="904875" y="5314503"/>
-            <a:ext cx="945802" cy="252412"/>
-          </a:xfrm>
-          <a:prstGeom prst="rect">
-            <a:avLst/>
-          </a:prstGeom>
-          <a:noFill/>
-        </p:spPr>
-        <p:txBody>
-          <a:bodyPr wrap="square" lIns="0" rIns="0" tIns="0" bIns="0" anchor="t"/>
-          <a:lstStyle/>
-          <a:p>
-            <a:pPr algn="l">
-              <a:lnSpc>
-                <a:spcPts val="862"/>
-              </a:lnSpc>
-            </a:pPr>
-            <a:r>
-              <a:rPr sz="750" b="0" i="0" spc="45">
-                <a:solidFill>
-                  <a:srgbClr val="FFFFFF"/>
-                </a:solidFill>
-                <a:latin typeface="Futura"/>
-                <a:ea typeface="Futura"/>
-                <a:cs typeface="Futura"/>
-              </a:rPr>
-              <a:t>EQUAL HOUSING</a:t>
-            </a:r>
-          </a:p>
-          <a:p>
-            <a:pPr algn="l">
-              <a:lnSpc>
-                <a:spcPts val="862"/>
-              </a:lnSpc>
-            </a:pPr>
-            <a:r>
-              <a:rPr sz="750" b="0" i="0" spc="45">
-                <a:solidFill>
-                  <a:srgbClr val="FFFFFF"/>
-                </a:solidFill>
-                <a:latin typeface="Futura"/>
-                <a:ea typeface="Futura"/>
-                <a:cs typeface="Futura"/>
-              </a:rPr>
-              <a:t>OPPORTUNITY</a:t>
-            </a:r>
-          </a:p>
-        </p:txBody>
-      </p:sp>
-      <p:sp>
-        <p:nvSpPr>
-          <p:cNvPr id="22" name="Rectangle 21"/>
-          <p:cNvSpPr/>
-          <p:nvPr/>
-        </p:nvSpPr>
-        <p:spPr>
-          <a:xfrm>
-            <a:off x="1860202" y="5301704"/>
-            <a:ext cx="6994" cy="282773"/>
-          </a:xfrm>
-          <a:prstGeom prst="rect">
-            <a:avLst/>
-          </a:prstGeom>
-          <a:solidFill>
-            <a:srgbClr val="969696"/>
-          </a:solidFill>
-          <a:ln>
-            <a:noFill/>
-          </a:ln>
-          <a:effectLst/>
-        </p:spPr>
-        <p:style>
-          <a:lnRef idx="1">
-            <a:schemeClr val="accent1"/>
-          </a:lnRef>
-          <a:fillRef idx="3">
-            <a:schemeClr val="accent1"/>
-          </a:fillRef>
-          <a:effectRef idx="2">
-            <a:schemeClr val="accent1"/>
-          </a:effectRef>
-          <a:fontRef idx="minor">
-            <a:schemeClr val="lt1"/>
-          </a:fontRef>
-        </p:style>
-        <p:txBody>
-          <a:bodyPr rtlCol="0" anchor="ctr"/>
-          <a:lstStyle/>
-          <a:p>
-            <a:pPr algn="ctr"/>
-          </a:p>
-        </p:txBody>
-      </p:sp>
-      <p:sp>
-        <p:nvSpPr>
-          <p:cNvPr id="23" name="TextBox 22"/>
-          <p:cNvSpPr txBox="1"/>
-          <p:nvPr/>
-        </p:nvSpPr>
-        <p:spPr>
-          <a:xfrm>
-            <a:off x="1971972" y="5292179"/>
-            <a:ext cx="9178822" cy="293786"/>
-          </a:xfrm>
-          <a:prstGeom prst="rect">
-            <a:avLst/>
-          </a:prstGeom>
-          <a:noFill/>
-        </p:spPr>
-        <p:txBody>
-          <a:bodyPr wrap="square" lIns="0" rIns="0" tIns="0" bIns="0" anchor="t"/>
-          <a:lstStyle/>
-          <a:p>
-            <a:pPr algn="l">
-              <a:lnSpc>
-                <a:spcPts val="1113"/>
-              </a:lnSpc>
-            </a:pPr>
-            <a:r>
-              <a:rPr sz="825" b="0" i="0" spc="16">
-                <a:solidFill>
-                  <a:srgbClr val="FFFFFF"/>
-                </a:solidFill>
-                <a:latin typeface="Futura"/>
-                <a:ea typeface="Futura"/>
-                <a:cs typeface="Futura"/>
-              </a:rPr>
-              <a:t>CONVENTIONAL FINANCING OFFERED BY EUSTIS MORTGAGE CORPORATION. NOT A COMMITMENT TO LEND. ALL BORROWERS ARE SUBJECT TO CREDIT APPROVAL. RATES AND TERMS MAY CHANGE AT ANYTIME WITHOUT NOTICE. NMLS #70345</a:t>
-            </a:r>
-          </a:p>
-        </p:txBody>
-      </p:sp>
     </p:spTree>
   </p:cSld>
   <p:clrMapOvr>

</xml_diff>